<commit_message>
ICLR 2027: add the Qwen3-32B raw-format panel to fig2/fig5 and rebuild deck v3
Co-Authored-By: Claude Fable 5.1 <noreply@anthropic.com>
</commit_message>
<xml_diff>
--- a/iclr2027/iclr2027_results_2026-09-15_v3.pptx
+++ b/iclr2027/iclr2027_results_2026-09-15_v3.pptx
@@ -3695,7 +3695,7 @@
         <p:spPr>
           <a:xfrm>
             <a:off x="365760" y="1385880"/>
-            <a:ext cx="11460175" cy="4045459"/>
+            <a:ext cx="11460175" cy="3574161"/>
           </a:xfrm>
           <a:prstGeom prst="rect">
             <a:avLst/>
@@ -8624,7 +8624,7 @@
         <p:spPr>
           <a:xfrm>
             <a:off x="365760" y="1097280"/>
-            <a:ext cx="11460175" cy="3523720"/>
+            <a:ext cx="11460175" cy="3249391"/>
           </a:xfrm>
           <a:prstGeom prst="rect">
             <a:avLst/>

</xml_diff>